<commit_message>
Fix export charts: colors, currency, Word chart images, XML escaping
</commit_message>
<xml_diff>
--- a/report.pptx
+++ b/report.pptx
@@ -137,11 +137,59 @@
               </c:strCache>
             </c:strRef>
           </c:tx>
+          <c:dPt>
+            <c:idx val="0"/>
+            <c:spPr>
+              <a:solidFill>
+                <a:srgbClr val="2563EB"/>
+              </a:solidFill>
+            </c:spPr>
+          </c:dPt>
+          <c:dPt>
+            <c:idx val="1"/>
+            <c:spPr>
+              <a:solidFill>
+                <a:srgbClr val="F97316"/>
+              </a:solidFill>
+            </c:spPr>
+          </c:dPt>
+          <c:dPt>
+            <c:idx val="2"/>
+            <c:spPr>
+              <a:solidFill>
+                <a:srgbClr val="16A34A"/>
+              </a:solidFill>
+            </c:spPr>
+          </c:dPt>
+          <c:dPt>
+            <c:idx val="3"/>
+            <c:spPr>
+              <a:solidFill>
+                <a:srgbClr val="EF4444"/>
+              </a:solidFill>
+            </c:spPr>
+          </c:dPt>
+          <c:dPt>
+            <c:idx val="4"/>
+            <c:spPr>
+              <a:solidFill>
+                <a:srgbClr val="8B5CF6"/>
+              </a:solidFill>
+            </c:spPr>
+          </c:dPt>
+          <c:dPt>
+            <c:idx val="5"/>
+            <c:spPr>
+              <a:solidFill>
+                <a:srgbClr val="EC4899"/>
+              </a:solidFill>
+            </c:spPr>
+          </c:dPt>
           <c:cat>
             <c:strRef>
-              <c:f>Sheet1!$A$2:$A$5</c:f>
+              <c:f>Sheet1!$A$2:$A$7</c:f>
               <c:strCache>
-                <c:ptCount val="4"/>
+                <c:ptCount val="6"/>
                 <c:pt idx="0">
                   <c:v>ABUJA</c:v>
                 </c:pt>
@@ -149,38 +197,50 @@
                   <c:v>LAGOS</c:v>
                 </c:pt>
                 <c:pt idx="2">
+                  <c:v>KANO</c:v>
+                </c:pt>
+                <c:pt idx="3">
                   <c:v>YOLA</c:v>
                 </c:pt>
-                <c:pt idx="3">
-                  <c:v>KANO</c:v>
+                <c:pt idx="4">
+                  <c:v>MAIDUGURI</c:v>
+                </c:pt>
+                <c:pt idx="5">
+                  <c:v>JALINGO</c:v>
                 </c:pt>
               </c:strCache>
             </c:strRef>
           </c:cat>
           <c:val>
             <c:numRef>
-              <c:f>Sheet1!$B$2:$B$5</c:f>
+              <c:f>Sheet1!$B$2:$B$7</c:f>
               <c:numCache>
                 <c:formatCode>General</c:formatCode>
-                <c:ptCount val="4"/>
+                <c:ptCount val="6"/>
                 <c:pt idx="0">
-                  <c:v>362518542.0</c:v>
+                  <c:v>330932447.0</c:v>
                 </c:pt>
                 <c:pt idx="1">
-                  <c:v>115684817.0</c:v>
+                  <c:v>84788759.0</c:v>
                 </c:pt>
                 <c:pt idx="2">
-                  <c:v>26737000.0</c:v>
+                  <c:v>56924478.0</c:v>
                 </c:pt>
                 <c:pt idx="3">
-                  <c:v>3000000.0</c:v>
+                  <c:v>15751350.0</c:v>
+                </c:pt>
+                <c:pt idx="4">
+                  <c:v>11838740.0</c:v>
+                </c:pt>
+                <c:pt idx="5">
+                  <c:v>7835114.0</c:v>
                 </c:pt>
               </c:numCache>
             </c:numRef>
           </c:val>
         </c:ser>
         <c:dLbls>
-          <c:numFmt formatCode="$#,##0" sourceLinked="0"/>
+          <c:numFmt formatCode="₦#,##0" sourceLinked="0"/>
           <c:showLegendKey val="0"/>
           <c:showVal val="1"/>
           <c:showCatName val="0"/>
@@ -242,99 +302,6 @@
 
 <file path=ppt/charts/chart2.xml><?xml version="1.0" encoding="utf-8"?>
 <c:chartSpace xmlns:c="http://schemas.openxmlformats.org/drawingml/2006/chart" xmlns:a="http://schemas.openxmlformats.org/drawingml/2006/main" xmlns:r="http://schemas.openxmlformats.org/officeDocument/2006/relationships">
-  <c:chart>
-    <c:autoTitleDeleted val="0"/>
-    <c:plotArea>
-      <c:pieChart>
-        <c:varyColors val="0"/>
-        <c:ser>
-          <c:idx val="0"/>
-          <c:order val="0"/>
-          <c:tx>
-            <c:strRef>
-              <c:f>Sheet1!$B$1</c:f>
-              <c:strCache>
-                <c:ptCount val="1"/>
-                <c:pt idx="0">
-                  <c:v>Bookings</c:v>
-                </c:pt>
-              </c:strCache>
-            </c:strRef>
-          </c:tx>
-          <c:cat>
-            <c:strRef>
-              <c:f>Sheet1!$A$2:$A$5</c:f>
-              <c:strCache>
-                <c:ptCount val="4"/>
-                <c:pt idx="0">
-                  <c:v>ABUJA</c:v>
-                </c:pt>
-                <c:pt idx="1">
-                  <c:v>LAGOS</c:v>
-                </c:pt>
-                <c:pt idx="2">
-                  <c:v>YOLA</c:v>
-                </c:pt>
-                <c:pt idx="3">
-                  <c:v>KANO</c:v>
-                </c:pt>
-              </c:strCache>
-            </c:strRef>
-          </c:cat>
-          <c:val>
-            <c:numRef>
-              <c:f>Sheet1!$B$2:$B$5</c:f>
-              <c:numCache>
-                <c:formatCode>General</c:formatCode>
-                <c:ptCount val="4"/>
-                <c:pt idx="0">
-                  <c:v>75.7</c:v>
-                </c:pt>
-                <c:pt idx="1">
-                  <c:v>19.3</c:v>
-                </c:pt>
-                <c:pt idx="2">
-                  <c:v>4.6</c:v>
-                </c:pt>
-                <c:pt idx="3">
-                  <c:v>0.4</c:v>
-                </c:pt>
-              </c:numCache>
-            </c:numRef>
-          </c:val>
-        </c:ser>
-        <c:dLbls>
-          <c:numFmt formatCode="0.0%" sourceLinked="0"/>
-          <c:showLegendKey val="0"/>
-          <c:showVal val="1"/>
-          <c:showCatName val="0"/>
-          <c:showSerName val="0"/>
-          <c:showPercent val="0"/>
-          <c:showBubbleSize val="0"/>
-          <c:showLeaderLines val="1"/>
-        </c:dLbls>
-      </c:pieChart>
-    </c:plotArea>
-    <c:dispBlanksAs val="gap"/>
-  </c:chart>
-  <c:txPr>
-    <a:bodyPr/>
-    <a:lstStyle/>
-    <a:p>
-      <a:pPr>
-        <a:defRPr sz="1800"/>
-      </a:pPr>
-      <a:endParaRPr lang="en-US"/>
-    </a:p>
-  </c:txPr>
-  <c:externalData r:id="rId1">
-    <c:autoUpdate val="0"/>
-  </c:externalData>
-</c:chartSpace>
-</file>
-
-<file path=ppt/charts/chart3.xml><?xml version="1.0" encoding="utf-8"?>
-<c:chartSpace xmlns:c="http://schemas.openxmlformats.org/drawingml/2006/chart" xmlns:a="http://schemas.openxmlformats.org/drawingml/2006/main" xmlns:r="http://schemas.openxmlformats.org/officeDocument/2006/relationships">
   <c:date1904 val="0"/>
   <c:chart>
     <c:autoTitleDeleted val="0"/>
@@ -352,11 +319,59 @@
               <c:strCache>
                 <c:ptCount val="1"/>
                 <c:pt idx="0">
-                  <c:v>AdCat</c:v>
+                  <c:v>Bill Amt</c:v>
                 </c:pt>
               </c:strCache>
             </c:strRef>
           </c:tx>
+          <c:dPt>
+            <c:idx val="0"/>
+            <c:spPr>
+              <a:solidFill>
+                <a:srgbClr val="2563EB"/>
+              </a:solidFill>
+            </c:spPr>
+          </c:dPt>
+          <c:dPt>
+            <c:idx val="1"/>
+            <c:spPr>
+              <a:solidFill>
+                <a:srgbClr val="F97316"/>
+              </a:solidFill>
+            </c:spPr>
+          </c:dPt>
+          <c:dPt>
+            <c:idx val="2"/>
+            <c:spPr>
+              <a:solidFill>
+                <a:srgbClr val="16A34A"/>
+              </a:solidFill>
+            </c:spPr>
+          </c:dPt>
+          <c:dPt>
+            <c:idx val="3"/>
+            <c:spPr>
+              <a:solidFill>
+                <a:srgbClr val="EF4444"/>
+              </a:solidFill>
+            </c:spPr>
+          </c:dPt>
+          <c:dPt>
+            <c:idx val="4"/>
+            <c:spPr>
+              <a:solidFill>
+                <a:srgbClr val="8B5CF6"/>
+              </a:solidFill>
+            </c:spPr>
+          </c:dPt>
+          <c:dPt>
+            <c:idx val="5"/>
+            <c:spPr>
+              <a:solidFill>
+                <a:srgbClr val="EC4899"/>
+              </a:solidFill>
+            </c:spPr>
+          </c:dPt>
           <c:cat>
             <c:strRef>
               <c:f>Sheet1!$A$2:$A$7</c:f>
@@ -369,16 +384,16 @@
                   <c:v>SPECIAL PROJECT</c:v>
                 </c:pt>
                 <c:pt idx="2">
-                  <c:v>CONGRATULATORY</c:v>
+                  <c:v>DISPLAY</c:v>
                 </c:pt>
                 <c:pt idx="3">
-                  <c:v>OBITUARY</c:v>
+                  <c:v>APPOINTMENT</c:v>
                 </c:pt>
                 <c:pt idx="4">
-                  <c:v>TENDER NOTICE</c:v>
+                  <c:v>TENDER</c:v>
                 </c:pt>
                 <c:pt idx="5">
-                  <c:v>CORPORATE</c:v>
+                  <c:v>ADVERTORIAL</c:v>
                 </c:pt>
               </c:strCache>
             </c:strRef>
@@ -390,29 +405,29 @@
                 <c:formatCode>General</c:formatCode>
                 <c:ptCount val="6"/>
                 <c:pt idx="0">
-                  <c:v>680.0</c:v>
+                  <c:v>246772020.0</c:v>
                 </c:pt>
                 <c:pt idx="1">
-                  <c:v>235.0</c:v>
+                  <c:v>99554949.0</c:v>
                 </c:pt>
                 <c:pt idx="2">
-                  <c:v>144.0</c:v>
+                  <c:v>51789450.0</c:v>
                 </c:pt>
                 <c:pt idx="3">
-                  <c:v>131.0</c:v>
+                  <c:v>41676525.0</c:v>
                 </c:pt>
                 <c:pt idx="4">
-                  <c:v>79.0</c:v>
+                  <c:v>35439600.0</c:v>
                 </c:pt>
                 <c:pt idx="5">
-                  <c:v>70.0</c:v>
+                  <c:v>32838344.0</c:v>
                 </c:pt>
               </c:numCache>
             </c:numRef>
           </c:val>
         </c:ser>
         <c:dLbls>
-          <c:numFmt formatCode="#,##0" sourceLinked="0"/>
+          <c:numFmt formatCode="₦#,##0" sourceLinked="0"/>
           <c:showLegendKey val="0"/>
           <c:showVal val="1"/>
           <c:showCatName val="0"/>
@@ -472,7 +487,7 @@
 </c:chartSpace>
 </file>
 
-<file path=ppt/charts/chart4.xml><?xml version="1.0" encoding="utf-8"?>
+<file path=ppt/charts/chart3.xml><?xml version="1.0" encoding="utf-8"?>
 <c:chartSpace xmlns:c="http://schemas.openxmlformats.org/drawingml/2006/chart" xmlns:a="http://schemas.openxmlformats.org/drawingml/2006/main" xmlns:r="http://schemas.openxmlformats.org/officeDocument/2006/relationships">
   <c:date1904 val="0"/>
   <c:chart>
@@ -495,8 +510,19 @@
               </c:strCache>
             </c:strRef>
           </c:tx>
+          <c:spPr>
+            <a:ln w="31750">
+              <a:solidFill>
+                <a:srgbClr val="2563EB"/>
+              </a:solidFill>
+            </a:ln>
+          </c:spPr>
           <c:marker>
-            <c:symbol val="none"/>
+            <c:spPr>
+              <a:solidFill>
+                <a:srgbClr val="2563EB"/>
+              </a:solidFill>
+            </c:spPr>
           </c:marker>
           <c:cat>
             <c:strRef>
@@ -504,13 +530,13 @@
               <c:strCache>
                 <c:ptCount val="3"/>
                 <c:pt idx="0">
-                  <c:v>2023-10</c:v>
+                  <c:v>October</c:v>
                 </c:pt>
                 <c:pt idx="1">
-                  <c:v>2023-11</c:v>
+                  <c:v>November</c:v>
                 </c:pt>
                 <c:pt idx="2">
-                  <c:v>2023-12</c:v>
+                  <c:v>December</c:v>
                 </c:pt>
               </c:strCache>
             </c:strRef>
@@ -536,7 +562,7 @@
           <c:smooth val="0"/>
         </c:ser>
         <c:dLbls>
-          <c:numFmt formatCode="$#,##0" sourceLinked="0"/>
+          <c:numFmt formatCode="₦#,##0" sourceLinked="0"/>
           <c:showLegendKey val="0"/>
           <c:showVal val="1"/>
           <c:showCatName val="0"/>
@@ -583,6 +609,132 @@
     <c:plotVisOnly val="1"/>
     <c:dispBlanksAs val="gap"/>
     <c:showDLblsOverMax val="0"/>
+  </c:chart>
+  <c:txPr>
+    <a:bodyPr/>
+    <a:lstStyle/>
+    <a:p>
+      <a:pPr>
+        <a:defRPr sz="1800"/>
+      </a:pPr>
+      <a:endParaRPr lang="en-US"/>
+    </a:p>
+  </c:txPr>
+  <c:externalData r:id="rId1">
+    <c:autoUpdate val="0"/>
+  </c:externalData>
+</c:chartSpace>
+</file>
+
+<file path=ppt/charts/chart4.xml><?xml version="1.0" encoding="utf-8"?>
+<c:chartSpace xmlns:c="http://schemas.openxmlformats.org/drawingml/2006/chart" xmlns:a="http://schemas.openxmlformats.org/drawingml/2006/main" xmlns:r="http://schemas.openxmlformats.org/officeDocument/2006/relationships">
+  <c:chart>
+    <c:autoTitleDeleted val="0"/>
+    <c:plotArea>
+      <c:pieChart>
+        <c:varyColors/>
+        <c:ser>
+          <c:idx val="0"/>
+          <c:order val="0"/>
+          <c:tx>
+            <c:strRef>
+              <c:f>Sheet1!$B$1</c:f>
+              <c:strCache>
+                <c:ptCount val="1"/>
+                <c:pt idx="0">
+                  <c:v>Bill Amt</c:v>
+                </c:pt>
+              </c:strCache>
+            </c:strRef>
+          </c:tx>
+          <c:dPt>
+            <c:idx val="0"/>
+            <c:spPr>
+              <a:solidFill>
+                <a:srgbClr val="2563EB"/>
+              </a:solidFill>
+            </c:spPr>
+          </c:dPt>
+          <c:dPt>
+            <c:idx val="1"/>
+            <c:spPr>
+              <a:solidFill>
+                <a:srgbClr val="F97316"/>
+              </a:solidFill>
+            </c:spPr>
+          </c:dPt>
+          <c:dPt>
+            <c:idx val="2"/>
+            <c:spPr>
+              <a:solidFill>
+                <a:srgbClr val="16A34A"/>
+              </a:solidFill>
+            </c:spPr>
+          </c:dPt>
+          <c:dPt>
+            <c:idx val="3"/>
+            <c:spPr>
+              <a:solidFill>
+                <a:srgbClr val="EF4444"/>
+              </a:solidFill>
+            </c:spPr>
+          </c:dPt>
+          <c:cat>
+            <c:strRef>
+              <c:f>Sheet1!$A$2:$A$5</c:f>
+              <c:strCache>
+                <c:ptCount val="4"/>
+                <c:pt idx="0">
+                  <c:v>PRE PAID</c:v>
+                </c:pt>
+                <c:pt idx="1">
+                  <c:v>CREDIT</c:v>
+                </c:pt>
+                <c:pt idx="2">
+                  <c:v>ADVANCE</c:v>
+                </c:pt>
+                <c:pt idx="3">
+                  <c:v>CASH</c:v>
+                </c:pt>
+              </c:strCache>
+            </c:strRef>
+          </c:cat>
+          <c:val>
+            <c:numRef>
+              <c:f>Sheet1!$B$2:$B$5</c:f>
+              <c:numCache>
+                <c:formatCode>General</c:formatCode>
+                <c:ptCount val="4"/>
+                <c:pt idx="0">
+                  <c:v>67.8</c:v>
+                </c:pt>
+                <c:pt idx="1">
+                  <c:v>19.2</c:v>
+                </c:pt>
+                <c:pt idx="2">
+                  <c:v>8.9</c:v>
+                </c:pt>
+                <c:pt idx="3">
+                  <c:v>4.1</c:v>
+                </c:pt>
+              </c:numCache>
+            </c:numRef>
+          </c:val>
+        </c:ser>
+        <c:dLbls>
+          <c:numFmt formatCode="0.0%" sourceLinked="0"/>
+          <c:showLegendKey val="0"/>
+          <c:showVal val="0"/>
+          <c:showCatName val="1"/>
+          <c:showSerName val="0"/>
+          <c:showPercent val="1"/>
+          <c:showBubbleSize val="0"/>
+          <c:showLeaderLines val="1"/>
+        </c:dLbls>
+      </c:pieChart>
+    </c:plotArea>
+    <c:legend/>
+    <c:dispBlanksAs val="gap"/>
   </c:chart>
   <c:txPr>
     <a:bodyPr/>
@@ -3630,7 +3782,7 @@
           <a:p>
             <a:r>
               <a:rPr sz="2400"/>
-              <a:t>Daily Trust Advertising Analytics Dashboard</a:t>
+              <a:t>Daily Trust Advertising Revenue Analysis</a:t>
             </a:r>
           </a:p>
         </p:txBody>
@@ -3704,7 +3856,7 @@
           <a:p>
             <a:r>
               <a:rPr sz="1800" b="0"/>
-              <a:t>This dataset contains 1,386 advertising booking records from Daily Trust newspaper across multiple locations in Nigeria from October to December 2023. The data shows a total revenue of ₦507.9 million with ABUJA being the dominant booking center handling 75.7% of all bookings. The average bill amount per booking is ₦366,609, with significant variations ranging from ₦0 to ₦5.65 million. Most advertisements are in color format (78.8%) and fall under the PUBLIC NOTICE category (49.1%). The business operates primarily on a PRE PAID payment model (82.2%) with an average discount rate of 21.2% applied to bookings.</a:t>
+              <a:t>This dataset contains 1,386 newspaper advertising records from Daily Trust, spanning October to December 2023. The data reveals advertising booking patterns, revenue distribution, and client behavior across different Nigerian locations. Key insights include revenue concentration in major cities, seasonal advertising trends, and the dominance of certain ad categories like Public Notice ads.</a:t>
             </a:r>
           </a:p>
         </p:txBody>
@@ -3779,35 +3931,35 @@
             <a:pPr/>
             <a:r>
               <a:rPr sz="1800"/>
-              <a:t>ABUJA dominates with 907 bookings (65.4% of total)</a:t>
+              <a:t>Total revenue generated: ₦507,753,852</a:t>
             </a:r>
           </a:p>
           <a:p>
             <a:pPr/>
             <a:r>
               <a:rPr sz="1800"/>
-              <a:t>Total revenue across all centers: ₦507,753,852</a:t>
+              <a:t>ABUJA leads all booking centers with ₦315,341,396 in revenue</a:t>
             </a:r>
           </a:p>
           <a:p>
             <a:pPr/>
             <a:r>
               <a:rPr sz="1800"/>
-              <a:t>Average discount rate applied: 21.2%</a:t>
+              <a:t>PUBLIC NOTICE is the dominant ad category with ₦321,913,960 in revenue</a:t>
             </a:r>
           </a:p>
           <a:p>
             <a:pPr/>
             <a:r>
               <a:rPr sz="1800"/>
-              <a:t>COLOR ads represent 64.4% of all bookings</a:t>
+              <a:t>Average discount rate is 21.2% across all bookings</a:t>
             </a:r>
           </a:p>
           <a:p>
             <a:pPr/>
             <a:r>
               <a:rPr sz="1800"/>
-              <a:t>PUBLIC NOTICE is the top ad category with 70.1% share</a:t>
+              <a:t>October had the highest monthly revenue at ₦174,997,095</a:t>
             </a:r>
           </a:p>
         </p:txBody>
@@ -3919,7 +4071,7 @@
           <a:p>
             <a:r>
               <a:rPr sz="2800" b="1"/>
-              <a:t>Bookings Distribution by Center</a:t>
+              <a:t>Revenue by Ad Category</a:t>
             </a:r>
           </a:p>
         </p:txBody>
@@ -3984,7 +4136,7 @@
           <a:p>
             <a:r>
               <a:rPr sz="2800" b="1"/>
-              <a:t>Top Advertisement Categories</a:t>
+              <a:t>Monthly Revenue Trend</a:t>
             </a:r>
           </a:p>
         </p:txBody>
@@ -4049,7 +4201,7 @@
           <a:p>
             <a:r>
               <a:rPr sz="2800" b="1"/>
-              <a:t>Monthly Revenue Trend</a:t>
+              <a:t>Payment Terms Distribution</a:t>
             </a:r>
           </a:p>
         </p:txBody>

</xml_diff>